<commit_message>
Met a jour le chapitre 3 de la Section 0 et le suivi des videos
Co-Authored-By: Claude Sonnet 5 <noreply@anthropic.com>
</commit_message>
<xml_diff>
--- a/livrables/formations/ecosysteme-ia/2026-09_vivier-ia-section-0-bienvenue/videos/01-bienvenue/chapitre-3/diapositives-chapitre-3.pptx
+++ b/livrables/formations/ecosysteme-ia/2026-09_vivier-ia-section-0-bienvenue/videos/01-bienvenue/chapitre-3/diapositives-chapitre-3.pptx
@@ -770,7 +770,7 @@
           <a:p>
             <a:r>
               <a:rPr lang="en-US" dirty="0"/>
-              <a:t>Moment du script : 3:48. La phrase apparaît seule, puis un clic pour l'appui.</a:t>
+              <a:t>Moment du script : 3:41. La phrase apparaît seule, puis un clic pour l'appui.</a:t>
             </a:r>
             <a:endParaRPr lang="en-US" dirty="0"/>
           </a:p>
@@ -858,7 +858,7 @@
           <a:p>
             <a:r>
               <a:rPr lang="en-US" dirty="0"/>
-              <a:t>Moment du script : 4:06. Le titre apparaît seul. Puis un clic par point, et un dernier clic pour l'annonce. Fin de la section 0.</a:t>
+              <a:t>Moment du script : 3:59. Le titre apparaît seul. Puis un clic par point, et un dernier clic pour l'annonce. Fin de la section 0.</a:t>
             </a:r>
             <a:endParaRPr lang="en-US" dirty="0"/>
           </a:p>

</xml_diff>